<commit_message>
LF3/LF9: Streudiagramme auf schlichte Measures (klare Achsenbeschriftung)
Die Kreis-Streudiagramme nutzten die (Geschlecht)-Measures ohne
Geschlechtsfilter - Werte korrekt (identisch zur Insgesamt-Quote,
max. 0,005 pp), aber die Achse beschriftete sich irrefuehrend als
"... (Geschlecht) %".

- LF3-Scatter: Quote ohne HSA (Geschlecht) % -> Quote ohne HSA %,
  Abiturquote (Geschlecht) % -> Abiturquote %.
- LF9-Scatter: Quote ohne HSA (Geschlecht) % -> Quote ohne HSA %.
- LF4 bleibt unveraendert (Geschlecht-Measures dort korrekt).
- .pbix neu exportiert, LF3/LF9-Bilder neu, DOCX/PPTX neu gebaut.
- verify_all 93/93 gruen.

Co-Authored-By: Claude Opus 4.8 <noreply@anthropic.com>
</commit_message>
<xml_diff>
--- a/Schulabschluss_DataStory_Praesentation.pptx
+++ b/Schulabschluss_DataStory_Praesentation.pptx
@@ -5172,8 +5172,8 @@
         </p:blipFill>
         <p:spPr>
           <a:xfrm>
-            <a:off x="5989320" y="2436333"/>
-            <a:ext cx="5943600" cy="3174052"/>
+            <a:off x="5989320" y="2436418"/>
+            <a:ext cx="5943600" cy="3173882"/>
           </a:xfrm>
           <a:prstGeom prst="rect">
             <a:avLst/>
@@ -8286,8 +8286,8 @@
         </p:blipFill>
         <p:spPr>
           <a:xfrm>
-            <a:off x="5989320" y="2131823"/>
-            <a:ext cx="5943600" cy="3783073"/>
+            <a:off x="5989320" y="2129332"/>
+            <a:ext cx="5943600" cy="3788054"/>
           </a:xfrm>
           <a:prstGeom prst="rect">
             <a:avLst/>

</xml_diff>

<commit_message>
Deliverables neu aus korrigiertem Bericht: Bild-Regeneration + DOCX/PPTX/PDF
Alle 9 Berichtsseiten frisch aus Power BI als PDF exportiert und zu
charts/pbi/pbi_lf*.png geschnitten (Auto-Bounding-Box, "Power BI Desktop"-
Export-Header sauber entfernt). Damit spiegeln die eingebetteten Bilder den
korrigierten Bericht wider – u.a.:
- LF6 relativ zeigt jetzt die richtige Achse (~41,6 je 1.000 statt Faktor-2 ~78),
  Chart und Text stimmen überein.
- LF1 zeigt die Sachsen-Anhalt-Hervorhebung (vermillion).
- LF4-KPIs und die jahr=2023-gepinnten Visuals auf Ist-Stand.

DOCX (p7) und PPTX (p6, 14 Folien/Notizen) neu gebaut; Präsentations-PDF aus
der neuen PPTX regeneriert; powerbi/SchulabschlussDataStory_bericht.pdf auf den
frischen Export aktualisiert. verify_all 93/93 grün.

Co-Authored-By: Claude Opus 4.8 <noreply@anthropic.com>
</commit_message>
<xml_diff>
--- a/Schulabschluss_DataStory_Praesentation.pptx
+++ b/Schulabschluss_DataStory_Praesentation.pptx
@@ -4778,8 +4778,8 @@
         </p:blipFill>
         <p:spPr>
           <a:xfrm>
-            <a:off x="5989320" y="2504677"/>
-            <a:ext cx="5943600" cy="3037365"/>
+            <a:off x="5989320" y="2264054"/>
+            <a:ext cx="5943600" cy="3518611"/>
           </a:xfrm>
           <a:prstGeom prst="rect">
             <a:avLst/>
@@ -5172,8 +5172,8 @@
         </p:blipFill>
         <p:spPr>
           <a:xfrm>
-            <a:off x="5989320" y="2436418"/>
-            <a:ext cx="5943600" cy="3173882"/>
+            <a:off x="5989320" y="2353208"/>
+            <a:ext cx="5943600" cy="3340303"/>
           </a:xfrm>
           <a:prstGeom prst="rect">
             <a:avLst/>
@@ -7892,8 +7892,8 @@
         </p:blipFill>
         <p:spPr>
           <a:xfrm>
-            <a:off x="5989320" y="2749294"/>
-            <a:ext cx="5943600" cy="2548131"/>
+            <a:off x="5989320" y="2373020"/>
+            <a:ext cx="5943600" cy="3300679"/>
           </a:xfrm>
           <a:prstGeom prst="rect">
             <a:avLst/>
@@ -8286,8 +8286,8 @@
         </p:blipFill>
         <p:spPr>
           <a:xfrm>
-            <a:off x="5989320" y="2129332"/>
-            <a:ext cx="5943600" cy="3788054"/>
+            <a:off x="5989320" y="2061972"/>
+            <a:ext cx="5943600" cy="3922776"/>
           </a:xfrm>
           <a:prstGeom prst="rect">
             <a:avLst/>
@@ -8680,8 +8680,8 @@
         </p:blipFill>
         <p:spPr>
           <a:xfrm>
-            <a:off x="5989320" y="2099127"/>
-            <a:ext cx="5943600" cy="3848465"/>
+            <a:off x="5989320" y="2353208"/>
+            <a:ext cx="5943600" cy="3340303"/>
           </a:xfrm>
           <a:prstGeom prst="rect">
             <a:avLst/>
@@ -10038,8 +10038,8 @@
         </p:blipFill>
         <p:spPr>
           <a:xfrm>
-            <a:off x="5989320" y="2886151"/>
-            <a:ext cx="5943600" cy="2274417"/>
+            <a:off x="5989320" y="2345283"/>
+            <a:ext cx="5943600" cy="3356152"/>
           </a:xfrm>
           <a:prstGeom prst="rect">
             <a:avLst/>

</xml_diff>

<commit_message>
Runde 3 – Deliverables + Doku: Bilder/DOCX/PPTX/PDF neu, Entscheidungsprotokoll
- Alle 9 LF-Seiten frisch exportiert und gecroppt (10-Seiten-PDF, Intro
  übersprungen); DOCX, PPTX (14 Folien/Notizen) und Präsentations-PDF neu.
- REVIEW_BEFUND.md: Runde-3-Entscheidungsprotokoll (LF9 Top-10 statt Gradient,
  Scatter bleibt, LF1-Linie behalten, LF2-Karte behalten + Werkzeug-Grenze,
  Slicer-Sync bewusst nicht, Drillthrough verschoben).
- BEFUNDE_UND_KORREKTUREN.md: Werkzeug-Grenze "kein natives Kreis-Choropleth"
  (Shape Map braucht TopoJSON, Filled Map geocodiert nur Namen/Doppelnamen).

Co-Authored-By: Claude Opus 4.8 <noreply@anthropic.com>
</commit_message>
<xml_diff>
--- a/Schulabschluss_DataStory_Praesentation.pptx
+++ b/Schulabschluss_DataStory_Praesentation.pptx
@@ -4778,8 +4778,8 @@
         </p:blipFill>
         <p:spPr>
           <a:xfrm>
-            <a:off x="6168774" y="1737360"/>
-            <a:ext cx="5584690" cy="4572000"/>
+            <a:off x="5989320" y="2087727"/>
+            <a:ext cx="5943600" cy="3871264"/>
           </a:xfrm>
           <a:prstGeom prst="rect">
             <a:avLst/>
@@ -5172,8 +5172,8 @@
         </p:blipFill>
         <p:spPr>
           <a:xfrm>
-            <a:off x="5989320" y="2341321"/>
-            <a:ext cx="5943600" cy="3364077"/>
+            <a:off x="5989320" y="2325471"/>
+            <a:ext cx="5943600" cy="3395776"/>
           </a:xfrm>
           <a:prstGeom prst="rect">
             <a:avLst/>
@@ -7892,8 +7892,8 @@
         </p:blipFill>
         <p:spPr>
           <a:xfrm>
-            <a:off x="5989320" y="2063953"/>
-            <a:ext cx="5943600" cy="3918813"/>
+            <a:off x="5989320" y="2087727"/>
+            <a:ext cx="5943600" cy="3871264"/>
           </a:xfrm>
           <a:prstGeom prst="rect">
             <a:avLst/>
@@ -8286,8 +8286,8 @@
         </p:blipFill>
         <p:spPr>
           <a:xfrm>
-            <a:off x="5989320" y="2111502"/>
-            <a:ext cx="5943600" cy="3823716"/>
+            <a:off x="5989320" y="2087727"/>
+            <a:ext cx="5943600" cy="3871264"/>
           </a:xfrm>
           <a:prstGeom prst="rect">
             <a:avLst/>
@@ -8680,8 +8680,8 @@
         </p:blipFill>
         <p:spPr>
           <a:xfrm>
-            <a:off x="5989320" y="2353208"/>
-            <a:ext cx="5943600" cy="3340303"/>
+            <a:off x="5989320" y="2325471"/>
+            <a:ext cx="5943600" cy="3395776"/>
           </a:xfrm>
           <a:prstGeom prst="rect">
             <a:avLst/>
@@ -10038,8 +10038,8 @@
         </p:blipFill>
         <p:spPr>
           <a:xfrm>
-            <a:off x="5989320" y="2333396"/>
-            <a:ext cx="5943600" cy="3379927"/>
+            <a:off x="5989320" y="2317546"/>
+            <a:ext cx="5943600" cy="3411626"/>
           </a:xfrm>
           <a:prstGeom prst="rect">
             <a:avLst/>

</xml_diff>

<commit_message>
LF3: StdAbw-Tabelle deutlich vergroessert; Namen-auf-Achse ehrlich getestet
- StdAbw-Tabelle auf der LF3-Seite stark vergroessert (x=704, 552x460, Schrift 14 pt) -
  die Streuungswerte je Bundesland sind jetzt prominent lesbar; pbi_lf3.png + DOCX/PPTX neu.
- Bundesland-NAMEN statt Positionsnummern auf der Dot-Plot-Achse: zweiten nativen Weg
  (Liniendiagramm, X=Land kategorial, Serie=Kreis, nur Marker) live getestet und VERWORFEN -
  Power BI reduziert bei ~400 Serien die Daten (i-Warnung, Punkte fehlen, Achse zerfaellt).
  SVG-Variante auf Teamwunsch nicht eingesetzt. Befund in BEFUNDE §8 dokumentiert;
  sauberer Namens-Weg bleibt Deneb (Anleitung + Specs liegen bereit).
- verify_all: 107/107 gruen; .pbip = .pbix.

Co-Authored-By: Claude Opus 4.8 <noreply@anthropic.com>
</commit_message>
<xml_diff>
--- a/Schulabschluss_DataStory_Praesentation.pptx
+++ b/Schulabschluss_DataStory_Praesentation.pptx
@@ -8286,8 +8286,8 @@
         </p:blipFill>
         <p:spPr>
           <a:xfrm>
-            <a:off x="5989320" y="2083765"/>
-            <a:ext cx="5943600" cy="3879189"/>
+            <a:off x="5989320" y="2287828"/>
+            <a:ext cx="5943600" cy="3471062"/>
           </a:xfrm>
           <a:prstGeom prst="rect">
             <a:avLst/>

</xml_diff>

<commit_message>
Runde 7: LF4 – "Gap" -> "Abweichung zwischen den Geschlechtern", KPI groesser + Bundesland-Filter
- 2 Delta-Karten: grosse Zahl (54pt), Kategorie-Label aus, Titel "Abweichung zwischen den Geschlechtern – ohne HSA/Abitur (pp)"
- Neuer Bundesland-Slicer (dim_region[Land], Einzelauswahl, Standard: Deutschland); Karten + Saeulen von ebene='DE' auf ebene IN (DE,BL) umgestellt -> Drilldown je Bundesland (alle 16 Laender datenseitig belegt, Gap 1,6-4,8 pp)
- Erkenntnis-Text + DOCX/PPTX-Captions + README + visual_spezifikation nachgezogen
- pbi_lf4.png neu gecroppt; .pbix + bericht.pdf neu exportiert
- verify_all 108/108 (neuer LF4-Regressionsguard)

Co-Authored-By: Claude Fable 5 <noreply@anthropic.com>
</commit_message>
<xml_diff>
--- a/Schulabschluss_DataStory_Praesentation.pptx
+++ b/Schulabschluss_DataStory_Praesentation.pptx
@@ -8680,8 +8680,8 @@
         </p:blipFill>
         <p:spPr>
           <a:xfrm>
-            <a:off x="5989320" y="2081783"/>
-            <a:ext cx="5943600" cy="3883152"/>
+            <a:off x="5989320" y="2380413"/>
+            <a:ext cx="5943600" cy="3285892"/>
           </a:xfrm>
           <a:prstGeom prst="rect">
             <a:avLst/>
@@ -8763,7 +8763,7 @@
                 </a:solidFill>
                 <a:latin typeface="Calibri"/>
               </a:rPr>
-              <a:t>•  Geschlechtergefälle in beide Richtungen</a:t>
+              <a:t>•  Abweichung zwischen den Geschlechtern in beide Richtungen</a:t>
             </a:r>
           </a:p>
           <a:p>
@@ -8782,7 +8782,7 @@
                 </a:solidFill>
                 <a:latin typeface="Calibri"/>
               </a:rPr>
-              <a:t>•  Deutschland, Abgangsjahr 2023</a:t>
+              <a:t>•  Standard Deutschland – je Bundesland filterbar (2023)</a:t>
             </a:r>
           </a:p>
         </p:txBody>

</xml_diff>

<commit_message>
Runde 10: LF9 – Balkendiagramm (höchste Risiko-Kreise) + "Verfügbares Einkommen je Einwohner (Euro)"
- Neues Balkendiagramm (barChart, TopN=8 hoechste Risiko-Kreise, Farbe Risiko LF9, Achse ab 0) rechts unter der Ranking-Tabelle; Tabelle auf alle 10 Zeilen erhoeht, Balken scrollfrei
- "Euro statt €-Zeichen" + Umbenennung: Einkommens-Schieberegler-Header, Tabellenspalte und Scatter-Tooltip -> "Verfügbares Einkommen je Einwohner (Euro)" bzw. "Verf. Einkommen (Euro/EW)"
- Live geprueft: Balken zeigt Gelsenkirchen..Gera (8 Kreise, vermillion, ohne Scrollbalken); Labels korrekt
- pbi_lf9.png neu gecroppt; .pbix + bericht.pdf neu exportiert; DOCX/README/visual_spezifikation ergaenzt
- verify_all 111/111 (neuer LF9-Regressionsguard)

Co-Authored-By: Claude Fable 5 <noreply@anthropic.com>
</commit_message>
<xml_diff>
--- a/Schulabschluss_DataStory_Praesentation.pptx
+++ b/Schulabschluss_DataStory_Praesentation.pptx
@@ -5172,8 +5172,8 @@
         </p:blipFill>
         <p:spPr>
           <a:xfrm>
-            <a:off x="5989320" y="2321509"/>
-            <a:ext cx="5943600" cy="3403701"/>
+            <a:off x="5989320" y="2380413"/>
+            <a:ext cx="5943600" cy="3285892"/>
           </a:xfrm>
           <a:prstGeom prst="rect">
             <a:avLst/>

</xml_diff>